<commit_message>
Poster: update to the latest results
Ada-ef cheaper than the fixed ef in 10/34 runs (was 11), PercEF's worst extra cost 2.5% (was
3.1%), 6 of the 9 non-Gaussian datasets are learned embeddings, the DARTH comparison, and the
objective worded as a comparison with Ada-ef and DARTH (not 'Ada-ef's own metrics'). Text
shortened where it overflowed; conclusions at 12 pt.

Co-Authored-By: Claude Opus 5.5 <noreply@anthropic.com>
Claude-Session: https://claude.ai/code/session_01RE6mmwrje1bnZRkuzuQPCF
</commit_message>
<xml_diff>
--- a/poster/PercEF_poster.pptx
+++ b/poster/PercEF_poster.pptx
@@ -1389,7 +1389,7 @@
                 <a:ea typeface="Arial" pitchFamily="34" charset="-122"/>
                 <a:cs typeface="Arial" pitchFamily="34" charset="-120"/>
               </a:rPr>
-              <a:t>Compare fairly on Ada-ef's own metrics: tail recall, cost, latency.</a:t>
+              <a:t>Compare fairly with Ada-ef and a learned method (DARTH).</a:t>
             </a:r>
             <a:endParaRPr lang="en-US" sz="1300" dirty="0"/>
           </a:p>
@@ -2817,7 +2817,7 @@
                 <a:ea typeface="Arial" pitchFamily="34" charset="-122"/>
                 <a:cs typeface="Arial" pitchFamily="34" charset="-120"/>
               </a:rPr>
-              <a:t>runs cheaper than the best fixed ef (Ada-ef: 11/34); never over +3.1%</a:t>
+              <a:t>runs cheaper than the best fixed ef (Ada-ef: 10/34); never over +2.5%</a:t>
             </a:r>
             <a:endParaRPr lang="en-US" sz="1100" dirty="0"/>
           </a:p>
@@ -3045,7 +3045,7 @@
               <a:buNone/>
             </a:pPr>
             <a:r>
-              <a:rPr lang="en-US" sz="1250" b="1" dirty="0">
+              <a:rPr lang="en-US" sz="1200" b="1" dirty="0">
                 <a:solidFill>
                   <a:srgbClr val="1F2933"/>
                 </a:solidFill>
@@ -3062,24 +3062,24 @@
               <a:buNone/>
             </a:pPr>
             <a:r>
-              <a:rPr lang="en-US" sz="1250" dirty="0">
-                <a:solidFill>
-                  <a:srgbClr val="1F2933"/>
-                </a:solidFill>
-                <a:latin typeface="Arial" pitchFamily="34" charset="0"/>
-                <a:ea typeface="Arial" pitchFamily="34" charset="-122"/>
-                <a:cs typeface="Arial" pitchFamily="34" charset="-120"/>
-              </a:rPr>
-              <a:t>Ada-ef's Gaussian model fails on 9 of 41 datasets, including SIFT and GIST. There PercEF restores per-query adaptation: better tail recall, at most 3.1% over the best fixed ef.</a:t>
-            </a:r>
-            <a:endParaRPr lang="en-US" sz="1250" dirty="0"/>
+              <a:rPr lang="en-US" sz="1200" dirty="0">
+                <a:solidFill>
+                  <a:srgbClr val="1F2933"/>
+                </a:solidFill>
+                <a:latin typeface="Arial" pitchFamily="34" charset="0"/>
+                <a:ea typeface="Arial" pitchFamily="34" charset="-122"/>
+                <a:cs typeface="Arial" pitchFamily="34" charset="-120"/>
+              </a:rPr>
+              <a:t>Ada-ef's Gaussian model fails on 9 of 41 datasets (6 learned embeddings); there PercEF gives better tail recall, at most 2.5% over the best fixed ef.</a:t>
+            </a:r>
+            <a:endParaRPr lang="en-US" sz="1200" dirty="0"/>
           </a:p>
           <a:p>
             <a:pPr indent="0" marL="0">
               <a:buNone/>
             </a:pPr>
             <a:r>
-              <a:rPr lang="en-US" sz="1250" b="1" dirty="0">
+              <a:rPr lang="en-US" sz="1200" b="1" dirty="0">
                 <a:solidFill>
                   <a:srgbClr val="1F2933"/>
                 </a:solidFill>
@@ -3096,17 +3096,17 @@
               <a:buNone/>
             </a:pPr>
             <a:r>
-              <a:rPr lang="en-US" sz="1250" dirty="0">
-                <a:solidFill>
-                  <a:srgbClr val="1F2933"/>
-                </a:solidFill>
-                <a:latin typeface="Arial" pitchFamily="34" charset="0"/>
-                <a:ea typeface="Arial" pitchFamily="34" charset="-122"/>
-                <a:cs typeface="Arial" pitchFamily="34" charset="-120"/>
-              </a:rPr>
-              <a:t>Next: explain the SIFT-1B miss and handle cross-modal queries.</a:t>
-            </a:r>
-            <a:endParaRPr lang="en-US" sz="1250" dirty="0"/>
+              <a:rPr lang="en-US" sz="1200" dirty="0">
+                <a:solidFill>
+                  <a:srgbClr val="1F2933"/>
+                </a:solidFill>
+                <a:latin typeface="Arial" pitchFamily="34" charset="0"/>
+                <a:ea typeface="Arial" pitchFamily="34" charset="-122"/>
+                <a:cs typeface="Arial" pitchFamily="34" charset="-120"/>
+              </a:rPr>
+              <a:t>DARTH (learned): best tail, up to 2.3x slower. Next: the SIFT-1B miss, cross-modal queries.</a:t>
+            </a:r>
+            <a:endParaRPr lang="en-US" sz="1200" dirty="0"/>
           </a:p>
         </p:txBody>
       </p:sp>

</xml_diff>

<commit_message>
Team names and SRNs on the deck title slide; note field for an alumnus without SRN
Co-Authored-By: Claude Opus 5.5 <noreply@anthropic.com>
Claude-Session: https://claude.ai/code/session_01RE6mmwrje1bnZRkuzuQPCF
</commit_message>
<xml_diff>
--- a/poster/PercEF_poster.pptx
+++ b/poster/PercEF_poster.pptx
@@ -2700,7 +2700,7 @@
                 <a:ea typeface="Arial" pitchFamily="34" charset="-122"/>
                 <a:cs typeface="Arial" pitchFamily="34" charset="-120"/>
               </a:rPr>
-              <a:t>16/16</a:t>
+              <a:t>15/16</a:t>
             </a:r>
             <a:endParaRPr lang="en-US" sz="2800" dirty="0"/>
           </a:p>
@@ -3190,7 +3190,7 @@
                 <a:ea typeface="Arial" pitchFamily="34" charset="-122"/>
                 <a:cs typeface="Arial" pitchFamily="34" charset="-120"/>
               </a:rPr>
-              <a:t>Member 1: Name</a:t>
+              <a:t>Pranav.N.Shenvi</a:t>
             </a:r>
             <a:endParaRPr lang="en-US" sz="1300" dirty="0"/>
           </a:p>
@@ -3207,7 +3207,7 @@
                 <a:ea typeface="Arial" pitchFamily="34" charset="-122"/>
                 <a:cs typeface="Arial" pitchFamily="34" charset="-120"/>
               </a:rPr>
-              <a:t>SRN</a:t>
+              <a:t>PES1UG23CS912</a:t>
             </a:r>
             <a:endParaRPr lang="en-US" sz="1300" dirty="0"/>
           </a:p>
@@ -3293,7 +3293,7 @@
                 <a:ea typeface="Arial" pitchFamily="34" charset="-122"/>
                 <a:cs typeface="Arial" pitchFamily="34" charset="-120"/>
               </a:rPr>
-              <a:t>Member 2: Name</a:t>
+              <a:t>M.G.Shrivardhan Swaroop</a:t>
             </a:r>
             <a:endParaRPr lang="en-US" sz="1300" dirty="0"/>
           </a:p>
@@ -3310,7 +3310,7 @@
                 <a:ea typeface="Arial" pitchFamily="34" charset="-122"/>
                 <a:cs typeface="Arial" pitchFamily="34" charset="-120"/>
               </a:rPr>
-              <a:t>SRN</a:t>
+              <a:t>PES1UG23CS334</a:t>
             </a:r>
             <a:endParaRPr lang="en-US" sz="1300" dirty="0"/>
           </a:p>
@@ -3419,7 +3419,7 @@
                 <a:ea typeface="Arial" pitchFamily="34" charset="-122"/>
                 <a:cs typeface="Arial" pitchFamily="34" charset="-120"/>
               </a:rPr>
-              <a:t>Member 3: Name</a:t>
+              <a:t>Megha H Shah</a:t>
             </a:r>
             <a:endParaRPr lang="en-US" sz="1300" dirty="0"/>
           </a:p>
@@ -3436,7 +3436,7 @@
                 <a:ea typeface="Arial" pitchFamily="34" charset="-122"/>
                 <a:cs typeface="Arial" pitchFamily="34" charset="-120"/>
               </a:rPr>
-              <a:t>SRN</a:t>
+              <a:t>PES1UG23CS354</a:t>
             </a:r>
             <a:endParaRPr lang="en-US" sz="1300" dirty="0"/>
           </a:p>
@@ -3545,7 +3545,7 @@
                 <a:ea typeface="Arial" pitchFamily="34" charset="-122"/>
                 <a:cs typeface="Arial" pitchFamily="34" charset="-120"/>
               </a:rPr>
-              <a:t>Member 4: Name</a:t>
+              <a:t>Kiran Hombal</a:t>
             </a:r>
             <a:endParaRPr lang="en-US" sz="1300" dirty="0"/>
           </a:p>
@@ -3562,7 +3562,7 @@
                 <a:ea typeface="Arial" pitchFamily="34" charset="-122"/>
                 <a:cs typeface="Arial" pitchFamily="34" charset="-120"/>
               </a:rPr>
-              <a:t>SRN</a:t>
+              <a:t>Alumnus, PhD at UIUC</a:t>
             </a:r>
             <a:endParaRPr lang="en-US" sz="1300" dirty="0"/>
           </a:p>
@@ -3671,7 +3671,7 @@
                 <a:ea typeface="Arial" pitchFamily="34" charset="-122"/>
                 <a:cs typeface="Arial" pitchFamily="34" charset="-120"/>
               </a:rPr>
-              <a:t>Guide: Name</a:t>
+              <a:t>Guide: Dr Shylaja S S</a:t>
             </a:r>
             <a:endParaRPr lang="en-US" sz="1300" dirty="0"/>
           </a:p>
@@ -3688,7 +3688,7 @@
                 <a:ea typeface="Arial" pitchFamily="34" charset="-122"/>
                 <a:cs typeface="Arial" pitchFamily="34" charset="-120"/>
               </a:rPr>
-              <a:t>Designation</a:t>
+              <a:t>Centre Director for CCBD/CDSAML</a:t>
             </a:r>
             <a:endParaRPr lang="en-US" sz="1300" dirty="0"/>
           </a:p>

</xml_diff>

<commit_message>
p1-matched comparison and the per-query cost explanation in the paper, deck and poster
Re-timing after the probe-score fix: recall, DC and p1 identical; time moved within noise
(faster than the fixed ef at equal mean recall 26/34, 8/16 non-Gaussian). Time lags work because
the queries PercEF calls hard cost ~8% more per distance even under a fixed ef
(analysis/query_cost.py, table3c). Matched on p1 instead of mean recall, PercEF is faster than the
fixed ef in 31/34 runs (13/16 non-Gaussian, median 15%), Ada-ef in 11/34 (1/16);
make_paper_figures.py reports both. updateAsOf071026.md.

Co-Authored-By: Claude Opus 5.5 <noreply@anthropic.com>
Claude-Session: https://claude.ai/code/session_01RE6mmwrje1bnZRkuzuQPCF
</commit_message>
<xml_diff>
--- a/poster/PercEF_poster.pptx
+++ b/poster/PercEF_poster.pptx
@@ -3070,7 +3070,7 @@
                 <a:ea typeface="Arial" pitchFamily="34" charset="-122"/>
                 <a:cs typeface="Arial" pitchFamily="34" charset="-120"/>
               </a:rPr>
-              <a:t>Ada-ef's Gaussian model fails on 9 of 41 datasets (6 learned embeddings); there PercEF gives better tail recall, at most 2.5% over the best fixed ef.</a:t>
+              <a:t>Ada-ef's Gaussian model fails on 9 of 41 datasets (6 learned embeddings); there PercEF gives better tail recall, at most 2.5% over the best fixed ef, and beats a fixed ef with the same worst case on time in 31 of 34 runs.</a:t>
             </a:r>
             <a:endParaRPr lang="en-US" sz="1200" dirty="0"/>
           </a:p>
@@ -3104,7 +3104,7 @@
                 <a:ea typeface="Arial" pitchFamily="34" charset="-122"/>
                 <a:cs typeface="Arial" pitchFamily="34" charset="-120"/>
               </a:rPr>
-              <a:t>DARTH (learned): best tail, up to 2.3x slower. Next: the SIFT-1B miss, cross-modal queries.</a:t>
+              <a:t>DARTH (learned): best tail, up to 2.3x slower. Next: SIFT-1B, cross-modal.</a:t>
             </a:r>
             <a:endParaRPr lang="en-US" sz="1200" dirty="0"/>
           </a:p>

</xml_diff>

<commit_message>
Worst case stated against the tuned fixed ef (13/16, Ada-ef 6/16); softer wording on the Gaussian model everywhere
'At least Ada-ef's tail recall in 15' counted a smaller loss (GIST) as a win; the paper, deck,
poster and script now say PercEF's p1 is at or above the fixed ef's in 13 of 16 runs (Ada-ef 6),
up to 8.8 points higher, and at most 1.5 lower in the other 3. Slide 11's chart is labelled as the
mean of settings P and R. 'Never tested' / 'fails' replaced by what Ada-ef's paper does and does not
report, and 'departs from the data'. Abstract 325 words.

Co-Authored-By: Claude Opus 5.5 <noreply@anthropic.com>
Claude-Session: https://claude.ai/code/session_01CJP5eznoFEsMkXGbeu2V17
</commit_message>
<xml_diff>
--- a/poster/PercEF_poster.pptx
+++ b/poster/PercEF_poster.pptx
@@ -1217,7 +1217,7 @@
                 <a:ea typeface="Arial" pitchFamily="34" charset="-122"/>
                 <a:cs typeface="Arial" pitchFamily="34" charset="-120"/>
               </a:rPr>
-              <a:t>Ada-ef (SIGMOD 2026) sets ef per query by assuming each query's similarities to the data are Gaussian. The assumption was never tested. We test it, and fix the method where it fails.</a:t>
+              <a:t>Ada-ef (SIGMOD 2026) sets ef per query by modelling each query's similarities to the data as Gaussian. We measure how well that fits on 41 datasets, and fix the method where it does not.</a:t>
             </a:r>
             <a:endParaRPr lang="en-US" sz="1300" dirty="0"/>
           </a:p>
@@ -2700,7 +2700,7 @@
                 <a:ea typeface="Arial" pitchFamily="34" charset="-122"/>
                 <a:cs typeface="Arial" pitchFamily="34" charset="-120"/>
               </a:rPr>
-              <a:t>15/16</a:t>
+              <a:t>13/16</a:t>
             </a:r>
             <a:endParaRPr lang="en-US" sz="2800" dirty="0"/>
           </a:p>
@@ -2739,7 +2739,7 @@
                 <a:ea typeface="Arial" pitchFamily="34" charset="-122"/>
                 <a:cs typeface="Arial" pitchFamily="34" charset="-120"/>
               </a:rPr>
-              <a:t>runs on non-Gaussian data: PercEF's tail recall at least Ada-ef's</a:t>
+              <a:t>non-Gaussian runs where PercEF's worst case is at or above a tuned fixed ef's (Ada-ef: 6/16)</a:t>
             </a:r>
             <a:endParaRPr lang="en-US" sz="1100" dirty="0"/>
           </a:p>
@@ -2948,7 +2948,7 @@
                 <a:ea typeface="Arial" pitchFamily="34" charset="-122"/>
                 <a:cs typeface="Arial" pitchFamily="34" charset="-120"/>
               </a:rPr>
-              <a:t>on near-Gaussian text embeddings Ada-ef keeps the better tail; neither method adapts when queries come from another modality (text searching images).</a:t>
+              <a:t>on near-Gaussian text embeddings Ada-ef gains more worst-case recall; neither method adapts when queries come from another modality (text searching images).</a:t>
             </a:r>
             <a:endParaRPr lang="en-US" sz="1150" dirty="0"/>
           </a:p>
@@ -3070,7 +3070,7 @@
                 <a:ea typeface="Arial" pitchFamily="34" charset="-122"/>
                 <a:cs typeface="Arial" pitchFamily="34" charset="-120"/>
               </a:rPr>
-              <a:t>Ada-ef's Gaussian model fails on 9 of 41 datasets (6 learned embeddings); there PercEF gives better tail recall, at most 2.5% over the best fixed ef, and beats a fixed ef with the same worst case on time in 31 of 34 runs.</a:t>
+              <a:t>Ada-ef's Gaussian model departs from the data on 9 of 41 datasets (6 learned embeddings); there PercEF keeps the worst case at or above a tuned fixed ef in 13 of 16 runs, at most 2.5% over its cost.</a:t>
             </a:r>
             <a:endParaRPr lang="en-US" sz="1200" dirty="0"/>
           </a:p>

</xml_diff>